<commit_message>
Refresh marketing assets and hardware readiness
</commit_message>
<xml_diff>
--- a/docs/sales-deck/Magic-Stick-Infografik-DE.pptx
+++ b/docs/sales-deck/Magic-Stick-Infografik-DE.pptx
@@ -2,13 +2,13 @@
 <file path=ppt/presentation.xml><?xml version="1.0" encoding="utf-8"?>
 <p:presentation xmlns:p="http://schemas.openxmlformats.org/presentationml/2006/main">
   <p:sldMasterIdLst>
-    <p:sldMasterId xmlns:r="http://schemas.openxmlformats.org/officeDocument/2006/relationships" id="2147483648" r:id="Rcc46330040d1425f"/>
+    <p:sldMasterId xmlns:r="http://schemas.openxmlformats.org/officeDocument/2006/relationships" id="2147483648" r:id="R01e6cbaf6a8a4d66"/>
   </p:sldMasterIdLst>
   <p:notesMasterIdLst>
-    <p:notesMasterId xmlns:r="http://schemas.openxmlformats.org/officeDocument/2006/relationships" r:id="R8dd3e5ca0bee45b8"/>
+    <p:notesMasterId xmlns:r="http://schemas.openxmlformats.org/officeDocument/2006/relationships" r:id="Ra0b233c766e748d7"/>
   </p:notesMasterIdLst>
   <p:sldIdLst>
-    <p:sldId xmlns:r="http://schemas.openxmlformats.org/officeDocument/2006/relationships" id="256" r:id="Rd7fc24c8c2754f83"/>
+    <p:sldId xmlns:r="http://schemas.openxmlformats.org/officeDocument/2006/relationships" id="256" r:id="R54e1cedbc88d42bb"/>
   </p:sldIdLst>
   <p:sldSz cx="13716000" cy="41148000"/>
   <p:notesSz cx="6858000" cy="9144000"/>
@@ -447,27 +447,27 @@
           </a:p>
           <a:p xmlns:a="http://schemas.openxmlformats.org/drawingml/2006/main">
             <a:r>
-              <a:t>- Hero artwork: docs/sales-deck/assets/Magic-Stick-Onepager-Hero.png.</a:t>
-            </a:r>
-          </a:p>
-          <a:p xmlns:a="http://schemas.openxmlformats.org/drawingml/2006/main">
-            <a:r>
-              <a:t>- Hybrid-model and tooling illustrations: retained public marketing assets from docs/sales-deck/Magic-Stick-Salesdeck-Dark-DE.pptx.</a:t>
-            </a:r>
-          </a:p>
-          <a:p xmlns:a="http://schemas.openxmlformats.org/drawingml/2006/main">
-            <a:r>
-              <a:t>- Dashboard capture: docs/sales-deck/assets/Magic-Stick-Dashboard-Instances.png.</a:t>
-            </a:r>
-          </a:p>
-          <a:p xmlns:a="http://schemas.openxmlformats.org/drawingml/2006/main">
-            <a:r>
-              <a:t>- Product claims are based on the current public Magic Stick repository and documentation. No external statistics or customer claims are used.</a:t>
-            </a:r>
-          </a:p>
-          <a:p xmlns:a="http://schemas.openxmlformats.org/drawingml/2006/main">
-            <a:r>
-              <a:t>- Enterprise capabilities are explicitly presented as a target concept, not as currently implemented functionality.</a:t>
+              <a:t>- Public repository state: 13b9d83 (2026-09-01).</a:t>
+            </a:r>
+          </a:p>
+          <a:p xmlns:a="http://schemas.openxmlformats.org/drawingml/2006/main">
+            <a:r>
+              <a:t>- docs/installation/README.md, docs/dashboard.md, docs/model-catalog.md, docs/modules.md and docs/authentication.md.</a:t>
+            </a:r>
+          </a:p>
+          <a:p xmlns:a="http://schemas.openxmlformats.org/drawingml/2006/main">
+            <a:r>
+              <a:t>- Existing Magic Stick hero and conceptual illustrations retained.</a:t>
+            </a:r>
+          </a:p>
+          <a:p xmlns:a="http://schemas.openxmlformats.org/drawingml/2006/main">
+            <a:r>
+              <a:t>- Product screenshot will be captured from the current test server in Chrome.</a:t>
+            </a:r>
+          </a:p>
+          <a:p xmlns:a="http://schemas.openxmlformats.org/drawingml/2006/main">
+            <a:r>
+              <a:t>- Enterprise capabilities are explicitly presented as a target concept in conception.</a:t>
             </a:r>
           </a:p>
         </p:txBody>
@@ -535,7 +535,7 @@
   </p:cSld>
   <p:clrMap bg1="lt1" tx1="dk1" bg2="lt2" tx2="dk2" accent1="accent1" accent2="accent2" accent3="accent3" accent4="accent4" accent5="accent5" accent6="accent6" hlink="hlink" folHlink="folHlink"/>
   <p:sldLayoutIdLst>
-    <p:sldLayoutId xmlns:r="http://schemas.openxmlformats.org/officeDocument/2006/relationships" id="2147483649" r:id="R92d4d12c32f7485b"/>
+    <p:sldLayoutId xmlns:r="http://schemas.openxmlformats.org/officeDocument/2006/relationships" id="2147483649" r:id="R246a64ee83e54022"/>
   </p:sldLayoutIdLst>
   <p:txStyles>
     <p:titleStyle>
@@ -1125,14 +1125,14 @@
       </p:sp>
       <p:pic>
         <p:nvPicPr>
-          <p:cNvPr id="100" name=""/>
+          <p:cNvPr id="105" name=""/>
           <p:cNvPicPr>
             <a:picLocks xmlns:a="http://schemas.openxmlformats.org/drawingml/2006/main" noChangeAspect="1"/>
           </p:cNvPicPr>
           <p:nvPr/>
         </p:nvPicPr>
         <p:blipFill>
-          <a:blip xmlns:r="http://schemas.openxmlformats.org/officeDocument/2006/relationships" xmlns:a="http://schemas.openxmlformats.org/drawingml/2006/main" r:embed="R08a55d85c66d4de4"/>
+          <a:blip xmlns:r="http://schemas.openxmlformats.org/officeDocument/2006/relationships" xmlns:a="http://schemas.openxmlformats.org/drawingml/2006/main" r:embed="R9fda37aa250544ce"/>
           <a:srcRect xmlns:a="http://schemas.openxmlformats.org/drawingml/2006/main" l="0" t="11458" r="0" b="11458"/>
           <a:stretch xmlns:a="http://schemas.openxmlformats.org/drawingml/2006/main">
             <a:fillRect l="0" t="0" r="0" b="0"/>
@@ -1445,7 +1445,7 @@
                 <a:ea typeface="Avenir Next"/>
                 <a:cs typeface="Avenir Next"/>
               </a:rPr>
-              <a:t>Magic Stick verbindet Installation, Modellzugang, Anwendungen und sichere Anmeldung auf Ihrer Infrastruktur.</a:t>
+              <a:t>Magic Stick verbindet Installation, Modellzugang, Services, SSO und GitOps-Betrieb auf Ihrer Infrastruktur.</a:t>
             </a:r>
           </a:p>
         </p:txBody>
@@ -2875,7 +2875,7 @@
                 <a:ea typeface="Avenir Next"/>
                 <a:cs typeface="Avenir Next"/>
               </a:rPr>
-              <a:t>Vom Installer zur reproduzierbaren Appliance.</a:t>
+              <a:t>USB-Installer; danach geschützter First Run.</a:t>
             </a:r>
           </a:p>
         </p:txBody>
@@ -3119,7 +3119,7 @@
                 <a:ea typeface="Avenir Next"/>
                 <a:cs typeface="Avenir Next"/>
               </a:rPr>
-              <a:t>Zum Beispiel in einer geeigneten Cloud-Umgebung.</a:t>
+              <a:t>Cloud-init; danach derselbe First Run.</a:t>
             </a:r>
           </a:p>
         </p:txBody>
@@ -3363,7 +3363,7 @@
                 <a:ea typeface="Avenir Next"/>
                 <a:cs typeface="Avenir Next"/>
               </a:rPr>
-              <a:t>Die vorhandene Maschine wird zur Plattformbasis.</a:t>
+              <a:t>Ein-Kommando-Skript für Ubuntu 24.04.</a:t>
             </a:r>
           </a:p>
         </p:txBody>
@@ -3607,7 +3607,7 @@
                 <a:ea typeface="Avenir Next"/>
                 <a:cs typeface="Avenir Next"/>
               </a:rPr>
-              <a:t>Magic Stick wird auf dem bestehenden Cluster ergänzt.</a:t>
+              <a:t>Bash- oder PowerShell-Deployment mit Flux.</a:t>
             </a:r>
           </a:p>
         </p:txBody>
@@ -3700,21 +3700,21 @@
                 <a:ea typeface="Avenir Next"/>
                 <a:cs typeface="Avenir Next"/>
               </a:rPr>
-              <a:t>MAGIC STICK · DEKLARATIV VERWALTETE PLATTFORM</a:t>
+              <a:t>MAGIC STICK · EIN ZIELZUSTAND · SICHERER FIRST RUN</a:t>
             </a:r>
           </a:p>
         </p:txBody>
       </p:sp>
       <p:pic>
         <p:nvPicPr>
-          <p:cNvPr id="148" name=""/>
+          <p:cNvPr id="153" name=""/>
           <p:cNvPicPr>
             <a:picLocks xmlns:a="http://schemas.openxmlformats.org/drawingml/2006/main" noChangeAspect="1"/>
           </p:cNvPicPr>
           <p:nvPr/>
         </p:nvPicPr>
         <p:blipFill>
-          <a:blip xmlns:r="http://schemas.openxmlformats.org/officeDocument/2006/relationships" xmlns:a="http://schemas.openxmlformats.org/drawingml/2006/main" r:embed="R6906c853b3ea41eb"/>
+          <a:blip xmlns:r="http://schemas.openxmlformats.org/officeDocument/2006/relationships" xmlns:a="http://schemas.openxmlformats.org/drawingml/2006/main" r:embed="R32a959effdcf42ff"/>
           <a:srcRect xmlns:a="http://schemas.openxmlformats.org/drawingml/2006/main" l="3244" t="0" r="3244" b="0"/>
           <a:stretch xmlns:a="http://schemas.openxmlformats.org/drawingml/2006/main">
             <a:fillRect l="0" t="0" r="0" b="0"/>
@@ -4037,7 +4037,7 @@
                 <a:ea typeface="Avenir Next"/>
                 <a:cs typeface="Avenir Next"/>
               </a:rPr>
-              <a:t>Ohne GPU beginnen.</a:t>
+              <a:t>Extern starten.</a:t>
             </a:r>
           </a:p>
           <a:p xmlns:a="http://schemas.openxmlformats.org/drawingml/2006/main">
@@ -4064,7 +4064,7 @@
                 <a:ea typeface="Avenir Next"/>
                 <a:cs typeface="Avenir Next"/>
               </a:rPr>
-              <a:t>Lokal erweitern.</a:t>
+              <a:t>Lokal passend skalieren.</a:t>
             </a:r>
           </a:p>
         </p:txBody>
@@ -4126,7 +4126,7 @@
                 <a:ea typeface="Avenir Next"/>
                 <a:cs typeface="Avenir Next"/>
               </a:rPr>
-              <a:t>Die Basisplattform benötigt keine GPU. Externe OpenAI-kompatible Modellendpunkte lassen sich über LiteLLM anbinden.</a:t>
+              <a:t>LiteLLM verbindet externe OpenAI-kompatible Provider. Dafür werden weder GPU noch KubeAI benötigt.</a:t>
             </a:r>
           </a:p>
         </p:txBody>
@@ -4188,7 +4188,7 @@
                 <a:ea typeface="Avenir Next"/>
                 <a:cs typeface="Avenir Next"/>
               </a:rPr>
-              <a:t>LOKAL, WENN ES PASST</a:t>
+              <a:t>VLLM UND OLLAMA</a:t>
             </a:r>
           </a:p>
         </p:txBody>
@@ -4250,7 +4250,7 @@
                 <a:ea typeface="Avenir Next"/>
                 <a:cs typeface="Avenir Next"/>
               </a:rPr>
-              <a:t>Lokale Modelle können bei Bedarf mit unterstützter NVIDIA-GPU und aktivierten GPU-/KubeAI-Modulen ergänzt werden.</a:t>
+              <a:t>vLLM: CPU, NVIDIA, AMD, Intel. Ollama: CPU, NVIDIA, AMD. Das Dashboard zeigt nur verfügbare Ziele und reserviert RAM oder VRAM.</a:t>
             </a:r>
           </a:p>
         </p:txBody>
@@ -4319,14 +4319,14 @@
       </p:sp>
       <p:pic>
         <p:nvPicPr>
-          <p:cNvPr id="159" name=""/>
+          <p:cNvPr id="164" name=""/>
           <p:cNvPicPr>
             <a:picLocks xmlns:a="http://schemas.openxmlformats.org/drawingml/2006/main" noChangeAspect="1"/>
           </p:cNvPicPr>
           <p:nvPr/>
         </p:nvPicPr>
         <p:blipFill>
-          <a:blip xmlns:r="http://schemas.openxmlformats.org/officeDocument/2006/relationships" xmlns:a="http://schemas.openxmlformats.org/drawingml/2006/main" r:embed="R292e6e7523494e73"/>
+          <a:blip xmlns:r="http://schemas.openxmlformats.org/officeDocument/2006/relationships" xmlns:a="http://schemas.openxmlformats.org/drawingml/2006/main" r:embed="R3da703a6a6b64cad"/>
           <a:srcRect xmlns:a="http://schemas.openxmlformats.org/drawingml/2006/main" l="9738" t="0" r="9738" b="0"/>
           <a:stretch xmlns:a="http://schemas.openxmlformats.org/drawingml/2006/main">
             <a:fillRect l="0" t="0" r="0" b="0"/>
@@ -4738,7 +4738,7 @@
                 <a:ea typeface="Avenir Next"/>
                 <a:cs typeface="Avenir Next"/>
               </a:rPr>
-              <a:t>Chat erschließt Wissen. Agenten bearbeiten Aufgaben. Coding-Werkzeuge helfen beim Entwickeln.</a:t>
+              <a:t>AnythingLLM bündelt Wissen. Instanzdienste bringen Chat, Agenten und Coding auf denselben Modellzugang.</a:t>
             </a:r>
           </a:p>
         </p:txBody>
@@ -4800,7 +4800,7 @@
                 <a:ea typeface="Avenir Next"/>
                 <a:cs typeface="Avenir Next"/>
               </a:rPr>
-              <a:t>CHAT</a:t>
+              <a:t>WISSEN</a:t>
             </a:r>
           </a:p>
           <a:p xmlns:a="http://schemas.openxmlformats.org/drawingml/2006/main">
@@ -4943,7 +4943,7 @@
                 <a:ea typeface="Avenir Next"/>
                 <a:cs typeface="Avenir Next"/>
               </a:rPr>
-              <a:t>Hermes · OpenClaw · Paperclip</a:t>
+              <a:t>OpenClaw · Hermes · Paperclip</a:t>
             </a:r>
           </a:p>
           <a:p xmlns:a="http://schemas.openxmlformats.org/drawingml/2006/main">
@@ -5224,7 +5224,7 @@
                 <a:ea typeface="Avenir Next"/>
                 <a:cs typeface="Avenir Next"/>
               </a:rPr>
-              <a:t>Eine Oberfläche. Alles im Blick.</a:t>
+              <a:t>Eine Oberfläche. Services, Modelle, Benutzer.</a:t>
             </a:r>
           </a:p>
         </p:txBody>
@@ -5286,7 +5286,7 @@
                 <a:ea typeface="Avenir Next"/>
                 <a:cs typeface="Avenir Next"/>
               </a:rPr>
-              <a:t>Das Dashboard verwaltet Module, Modellaktivierungen, Anwendungsinstanzen sowie lokale Benutzer und globale Magic-Stick-Rollen.</a:t>
+              <a:t>Die Services-Seite vereint Module und Instanzen. Modelle werden nach Engine und verfügbarer Hardware gefiltert; Nutzer und globale Rollen bleiben zentral verwaltbar.</a:t>
             </a:r>
           </a:p>
         </p:txBody>
@@ -5328,28 +5328,26 @@
       </p:sp>
       <p:pic>
         <p:nvPicPr>
-          <p:cNvPr id="176" name=""/>
+          <p:cNvPr id="181" name=""/>
           <p:cNvPicPr>
             <a:picLocks xmlns:a="http://schemas.openxmlformats.org/drawingml/2006/main" noChangeAspect="1"/>
           </p:cNvPicPr>
           <p:nvPr/>
         </p:nvPicPr>
         <p:blipFill>
-          <a:blip xmlns:r="http://schemas.openxmlformats.org/officeDocument/2006/relationships" xmlns:a="http://schemas.openxmlformats.org/drawingml/2006/main" r:embed="R9795949bfc5f43ba"/>
-          <a:srcRect xmlns:a="http://schemas.openxmlformats.org/drawingml/2006/main" l="0" t="22204" r="0" b="22204"/>
+          <a:blip xmlns:r="http://schemas.openxmlformats.org/officeDocument/2006/relationships" xmlns:a="http://schemas.openxmlformats.org/drawingml/2006/main" r:embed="R5d5a3196de874b7b"/>
+          <a:srcRect xmlns:a="http://schemas.openxmlformats.org/drawingml/2006/main" l="0" t="0" r="0" b="0"/>
           <a:stretch xmlns:a="http://schemas.openxmlformats.org/drawingml/2006/main">
             <a:fillRect l="0" t="0" r="0" b="0"/>
           </a:stretch>
         </p:blipFill>
         <p:spPr>
-          <a:xfrm xmlns:a="http://schemas.openxmlformats.org/drawingml/2006/main">
+          <a:xfrm xmlns:a="http://schemas.openxmlformats.org/drawingml/2006/main" flipH="0" flipV="0">
             <a:off x="1162050" y="31642050"/>
             <a:ext cx="7486650" cy="2247900"/>
           </a:xfrm>
           <a:prstGeom xmlns:a="http://schemas.openxmlformats.org/drawingml/2006/main" prst="roundRect">
-            <a:avLst>
-              <a:gd name="adj" fmla="val 7627"/>
-            </a:avLst>
+            <a:avLst/>
           </a:prstGeom>
         </p:spPr>
       </p:pic>
@@ -5410,7 +5408,7 @@
                 <a:ea typeface="Avenir Next"/>
                 <a:cs typeface="Avenir Next"/>
               </a:rPr>
-              <a:t>ECHTE PRODUKTOBERFLÄCHE · AKTUELLER ENTWICKLUNGSSTAND</a:t>
+              <a:t>AKTUELLE PRODUKTOBERFLÄCHE · BEISPIELKONFIGURATION</a:t>
             </a:r>
           </a:p>
         </p:txBody>
@@ -5623,7 +5621,7 @@
                 <a:ea typeface="Avenir Next"/>
                 <a:cs typeface="Avenir Next"/>
               </a:rPr>
-              <a:t>Dashboard und konfigurierte Routen werden über OIDC geschützt. Externe OIDC- oder SAML-Anbieter können über Keycloak angebunden werden.</a:t>
+              <a:t>Ein Konsolencode legt den ersten Admin ohne Default-Passwort an. Envoy schützt Dashboard und Routen; Keycloak kann externe OIDC-/SAML-Anbieter brokern.</a:t>
             </a:r>
           </a:p>
         </p:txBody>
@@ -5685,7 +5683,7 @@
                 <a:ea typeface="Avenir Next"/>
                 <a:cs typeface="Avenir Next"/>
               </a:rPr>
-              <a:t>Gateway-SSO; anwendungseigene Rollen bleiben anwendungsspezifisch.</a:t>
+              <a:t>Zentraler Gateway-Login; App-Rollen bleiben anwendungsspezifisch.</a:t>
             </a:r>
           </a:p>
         </p:txBody>
@@ -6136,7 +6134,7 @@
                 <a:ea typeface="Avenir Next"/>
                 <a:cs typeface="Avenir Next"/>
               </a:rPr>
-              <a:t>Offene Appliance-Basis, deklarative Verwaltung, zentrale Gateway-Anmeldung und flexible Modellanbindung.</a:t>
+              <a:t>Offene Appliance, Services, Modelle und Benutzer; globale Rollen sowie eine Mindestrolle pro Instanz.</a:t>
             </a:r>
           </a:p>
         </p:txBody>
@@ -6260,7 +6258,7 @@
                 <a:ea typeface="Avenir Next"/>
                 <a:cs typeface="Avenir Next"/>
               </a:rPr>
-              <a:t>Ressourcenbezogene Freigaben, Gruppenrichtlinien und delegierte Administration.</a:t>
+              <a:t>Nutzer-/Gruppenfreigaben je Ressource, organisatorische Scopes, delegierte Administration und Audit.</a:t>
             </a:r>
           </a:p>
         </p:txBody>
@@ -6425,7 +6423,7 @@
                 <a:latin typeface="Avenir Next"/>
                 <a:ea typeface="Avenir Next"/>
                 <a:cs typeface="Avenir Next"/>
-                <a:hlinkClick xmlns:r="http://schemas.openxmlformats.org/officeDocument/2006/relationships" r:id="Rb512739f257c43b1"/>
+                <a:hlinkClick xmlns:r="http://schemas.openxmlformats.org/officeDocument/2006/relationships" r:id="R29f872c1017b46ec"/>
               </a:rPr>
               <a:t>github.com/QualityMinds/AIppliance-Magic-Stick</a:t>
             </a:r>
@@ -6550,7 +6548,7 @@
                 <a:latin typeface="Avenir Next"/>
                 <a:ea typeface="Avenir Next"/>
                 <a:cs typeface="Avenir Next"/>
-                <a:hlinkClick xmlns:r="http://schemas.openxmlformats.org/officeDocument/2006/relationships" r:id="R1d41e889b4b042a8"/>
+                <a:hlinkClick xmlns:r="http://schemas.openxmlformats.org/officeDocument/2006/relationships" r:id="R5b79e471c80847ac"/>
               </a:rPr>
               <a:t>hello@qualityminds.de</a:t>
             </a:r>

</xml_diff>